<commit_message>
M6-F08: fundamentar escolhas e alinhar quatro fotografias
</commit_message>
<xml_diff>
--- a/m6/diapositivos/sessao-08-m6-f08.pptx
+++ b/m6/diapositivos/sessao-08-m6-f08.pptx
@@ -2615,7 +2615,7 @@
                 <a:ea typeface="Georgia" pitchFamily="34" charset="-122"/>
                 <a:cs typeface="Georgia" pitchFamily="34" charset="-120"/>
               </a:rPr>
-              <a:t>seis fotografias</a:t>
+              <a:t>quatro fotografias</a:t>
             </a:r>
             <a:pPr indent="0" marL="0">
               <a:lnSpc>
@@ -3215,7 +3215,7 @@
                 <a:ea typeface="Arial" pitchFamily="34" charset="-122"/>
                 <a:cs typeface="Arial" pitchFamily="34" charset="-120"/>
               </a:rPr>
-              <a:t>A encomenda são seis fotografias, uma curta de dois a três minutos ou o formato do teu curso, cada imagem ligada a um verso, citado com a parte do poema.</a:t>
+              <a:t>A encomenda são quatro fotografias, uma curta de dois a três minutos ou o formato do teu curso, cada imagem ligada a um verso, citado com a parte do poema.</a:t>
             </a:r>
             <a:endParaRPr lang="en-US" sz="2200" dirty="0"/>
           </a:p>

</xml_diff>